<commit_message>
Update docs and merge ClearChart app (wip)
</commit_message>
<xml_diff>
--- a/docs/ClearChart(nurse_notes)_Pitch.pptx
+++ b/docs/ClearChart(nurse_notes)_Pitch.pptx
@@ -6381,6 +6381,38 @@
               <a:t>Every discharge form leaves the ward in a form the patient understands — in their language, checked by a clinician, turning a legal right into a daily reality.</a:t>
             </a:r>
             <a:endParaRPr lang="en-US" dirty="0"/>
+          </a:p>
+        </p:txBody>
+      </p:sp>
+      <p:sp>
+        <p:nvSpPr>
+          <p:cNvPr id="21" name="TextBox 20"/>
+          <p:cNvSpPr txBox="1"/>
+          <p:nvPr/>
+        </p:nvSpPr>
+        <p:spPr>
+          <a:xfrm>
+            <a:off x="822960" y="5788152"/>
+            <a:ext cx="10515600" cy="457200"/>
+          </a:xfrm>
+          <a:prstGeom prst="rect">
+            <a:avLst/>
+          </a:prstGeom>
+          <a:noFill/>
+        </p:spPr>
+        <p:txBody>
+          <a:bodyPr wrap="square">
+            <a:spAutoFit/>
+          </a:bodyPr>
+          <a:lstStyle/>
+          <a:p>
+            <a:r>
+              <a:rPr b="1" sz="1700"/>
+              <a:t>Technical roadmap:  </a:t>
+            </a:r>
+            <a:r>
+              <a:t>Next build step is MedGemma 4B for structured medicine/date extraction (targets the 6/52 misparse directly). On-device de-identification (LLM-AIx/OpenMed) and simplification fine-tuning are scoped as post-hackathon future work, not claimed as built.</a:t>
+            </a:r>
           </a:p>
         </p:txBody>
       </p:sp>

</xml_diff>

<commit_message>
Overhaul pptx design, fix duplicate/overclaim bugs, add PIAAC reading-level section to docx
- pptx: fix slide 7 duplicate-run text, fix slide 8 overclaim (unshipped UI), apply subtle gradient backgrounds to content slides
- docx: add OECD PIAAC reading-level benchmark section (chart + legend) matching the linked Google Doc tab, inserted before Idea 7
</commit_message>
<xml_diff>
--- a/docs/ClearChart(nurse_notes)_Pitch.pptx
+++ b/docs/ClearChart(nurse_notes)_Pitch.pptx
@@ -1586,9 +1586,17 @@
   <p:cSld name="Slide 2">
     <p:bg>
       <p:bgPr>
-        <a:solidFill>
-          <a:srgbClr val="FFFFFF"/>
-        </a:solidFill>
+        <a:gradFill rotWithShape="1">
+          <a:gsLst>
+            <a:gs pos="0">
+              <a:srgbClr val="FFFFFF"/>
+            </a:gs>
+            <a:gs pos="100000">
+              <a:srgbClr val="F2FAF8"/>
+            </a:gs>
+          </a:gsLst>
+          <a:lin scaled="0" ang="16200000"/>
+        </a:gradFill>
         <a:effectLst/>
       </p:bgPr>
     </p:bg>
@@ -2242,9 +2250,17 @@
   <p:cSld name="Slide 3">
     <p:bg>
       <p:bgPr>
-        <a:solidFill>
-          <a:srgbClr val="FFFFFF"/>
-        </a:solidFill>
+        <a:gradFill rotWithShape="1">
+          <a:gsLst>
+            <a:gs pos="0">
+              <a:srgbClr val="FFFFFF"/>
+            </a:gs>
+            <a:gs pos="100000">
+              <a:srgbClr val="F2FAF8"/>
+            </a:gs>
+          </a:gsLst>
+          <a:lin scaled="0" ang="16200000"/>
+        </a:gradFill>
         <a:effectLst/>
       </p:bgPr>
     </p:bg>
@@ -2731,9 +2747,17 @@
   <p:cSld name="Slide 4">
     <p:bg>
       <p:bgPr>
-        <a:solidFill>
-          <a:srgbClr val="FFFFFF"/>
-        </a:solidFill>
+        <a:gradFill rotWithShape="1">
+          <a:gsLst>
+            <a:gs pos="0">
+              <a:srgbClr val="FFFFFF"/>
+            </a:gs>
+            <a:gs pos="100000">
+              <a:srgbClr val="F2FAF8"/>
+            </a:gs>
+          </a:gsLst>
+          <a:lin scaled="0" ang="16200000"/>
+        </a:gradFill>
         <a:effectLst/>
       </p:bgPr>
     </p:bg>
@@ -3431,9 +3455,17 @@
   <p:cSld name="Slide 5">
     <p:bg>
       <p:bgPr>
-        <a:solidFill>
-          <a:srgbClr val="FFFFFF"/>
-        </a:solidFill>
+        <a:gradFill rotWithShape="1">
+          <a:gsLst>
+            <a:gs pos="0">
+              <a:srgbClr val="FFFFFF"/>
+            </a:gs>
+            <a:gs pos="100000">
+              <a:srgbClr val="F2FAF8"/>
+            </a:gs>
+          </a:gsLst>
+          <a:lin scaled="0" ang="16200000"/>
+        </a:gradFill>
         <a:effectLst/>
       </p:bgPr>
     </p:bg>
@@ -3992,9 +4024,17 @@
   <p:cSld name="Slide 6">
     <p:bg>
       <p:bgPr>
-        <a:solidFill>
-          <a:srgbClr val="FFFFFF"/>
-        </a:solidFill>
+        <a:gradFill rotWithShape="1">
+          <a:gsLst>
+            <a:gs pos="0">
+              <a:srgbClr val="FFFFFF"/>
+            </a:gs>
+            <a:gs pos="100000">
+              <a:srgbClr val="F2FAF8"/>
+            </a:gs>
+          </a:gsLst>
+          <a:lin scaled="0" ang="16200000"/>
+        </a:gradFill>
         <a:effectLst/>
       </p:bgPr>
     </p:bg>
@@ -4955,9 +4995,17 @@
   <p:cSld name="Slide 7">
     <p:bg>
       <p:bgPr>
-        <a:solidFill>
-          <a:srgbClr val="FFFFFF"/>
-        </a:solidFill>
+        <a:gradFill rotWithShape="1">
+          <a:gsLst>
+            <a:gs pos="0">
+              <a:srgbClr val="FFFFFF"/>
+            </a:gs>
+            <a:gs pos="100000">
+              <a:srgbClr val="F2FAF8"/>
+            </a:gs>
+          </a:gsLst>
+          <a:lin scaled="0" ang="16200000"/>
+        </a:gradFill>
         <a:effectLst/>
       </p:bgPr>
     </p:bg>
@@ -5703,9 +5751,17 @@
   <p:cSld name="Slide 8">
     <p:bg>
       <p:bgPr>
-        <a:solidFill>
-          <a:srgbClr val="FFFFFF"/>
-        </a:solidFill>
+        <a:gradFill rotWithShape="1">
+          <a:gsLst>
+            <a:gs pos="0">
+              <a:srgbClr val="FFFFFF"/>
+            </a:gs>
+            <a:gs pos="100000">
+              <a:srgbClr val="F2FAF8"/>
+            </a:gs>
+          </a:gsLst>
+          <a:lin scaled="0" ang="16200000"/>
+        </a:gradFill>
         <a:effectLst/>
       </p:bgPr>
     </p:bg>
@@ -6411,7 +6467,7 @@
               <a:t>Technical roadmap:  Next: MedGemma 4B for structured medicine/date extraction (targets the 6/52 misparse). De-identification and simplification fine-tuning are post-hackathon future work. Since prototype: mobile patient view, QR save-to-phone, on-device TTS — all single-file/offline. Delivery roadmap: push approved rewrites into ManageMyHealth (NZ's largest patient portal).</a:t>
             </a:r>
             <a:r>
-              <a:t>Next build step is MedGemma 4B for structured medicine/date extraction (targets the 6/52 misparse directly). On-device de-identification (LLM-AIx/OpenMed) and simplification fine-tuning are scoped as post-hackathon future work, not claimed as built.</a:t>
+              <a:t/>
             </a:r>
           </a:p>
         </p:txBody>
@@ -6858,7 +6914,7 @@
                 <a:ea typeface="Calibri" pitchFamily="34" charset="-122"/>
                 <a:cs typeface="Calibri" pitchFamily="34" charset="-120"/>
               </a:rPr>
-              <a:t>Structure-over-prose UI; te reo &amp; Pacific output no rival ships.</a:t>
+              <a:t>Shipped safety UI, QR patient handoff, on-device TTS; te reo &amp; Pacific output no rival ships.</a:t>
             </a:r>
             <a:endParaRPr lang="en-US" sz="1300" dirty="0"/>
           </a:p>

</xml_diff>